<commit_message>
Remove dev-only references from intro deck
</commit_message>
<xml_diff>
--- a/slides/course_outline/introduction.pptx
+++ b/slides/course_outline/introduction.pptx
@@ -24273,7 +24273,7 @@
               </a:defRPr>
             </a:pPr>
             <a:r>
-              <a:t>•  Struttura: slides/, notebooks/, project/, data/, scripts/</a:t>
+              <a:t>•  Struttura: slides/, notebooks/, project/, data/</a:t>
             </a:r>
           </a:p>
           <a:p>
@@ -24466,10 +24466,6 @@
             <a:br/>
             <a:r>
               <a:t>├── data/            # CSV anonimizzati</a:t>
-            </a:r>
-            <a:br/>
-            <a:r>
-              <a:t>├── scripts/         # Utility Python</a:t>
             </a:r>
             <a:br/>
             <a:r>
@@ -24777,22 +24773,6 @@
             </a:pPr>
             <a:r>
               <a:t>•  matplotlib, networkx — Visualizzazione dati</a:t>
-            </a:r>
-          </a:p>
-          <a:p>
-            <a:pPr algn="l">
-              <a:spcAft>
-                <a:spcPts val="700"/>
-              </a:spcAft>
-              <a:defRPr sz="1300">
-                <a:solidFill>
-                  <a:srgbClr val="FFFFFF"/>
-                </a:solidFill>
-                <a:latin typeface="Calibri"/>
-              </a:defRPr>
-            </a:pPr>
-            <a:r>
-              <a:t>•  python-pptx — Generazione slide</a:t>
             </a:r>
           </a:p>
           <a:p>
@@ -25793,7 +25773,7 @@
               </a:defRPr>
             </a:pPr>
             <a:r>
-              <a:t>•  Ogni sessione: Slides (30-40%) + Notebook + Progetto (50-60%)</a:t>
+              <a:t>•  Ogni sessione: Slides (30-40%) + [Notebook + Progetto] (50-60%)</a:t>
             </a:r>
           </a:p>
           <a:p>
@@ -26306,7 +26286,7 @@
               </a:defRPr>
             </a:pPr>
             <a:r>
-              <a:t>2  Laboratorio (notebook)</a:t>
+              <a:t>2  Laboratorio + Progetto (notebook + Org Graph)</a:t>
             </a:r>
           </a:p>
         </p:txBody>
@@ -26342,11 +26322,11 @@
               </a:defRPr>
             </a:pPr>
             <a:r>
-              <a:t>Query interattive, esercitazioni guidate</a:t>
+              <a:t>Query interattive + applicazione al dataset aziendale</a:t>
             </a:r>
             <a:br/>
             <a:r>
-              <a:t>30–40 minuti</a:t>
+              <a:t>50–70 minuti</a:t>
             </a:r>
           </a:p>
         </p:txBody>
@@ -26359,126 +26339,7 @@
         </p:nvSpPr>
         <p:spPr>
           <a:xfrm>
-            <a:off x="731520" y="4206240"/>
-            <a:ext cx="73152" cy="1188720"/>
-          </a:xfrm>
-          <a:prstGeom prst="rect">
-            <a:avLst/>
-          </a:prstGeom>
-          <a:solidFill>
-            <a:srgbClr val="CCCCCC"/>
-          </a:solidFill>
-          <a:ln>
-            <a:noFill/>
-          </a:ln>
-        </p:spPr>
-        <p:style>
-          <a:lnRef idx="1">
-            <a:schemeClr val="accent1"/>
-          </a:lnRef>
-          <a:fillRef idx="3">
-            <a:schemeClr val="accent1"/>
-          </a:fillRef>
-          <a:effectRef idx="2">
-            <a:schemeClr val="accent1"/>
-          </a:effectRef>
-          <a:fontRef idx="minor">
-            <a:schemeClr val="lt1"/>
-          </a:fontRef>
-        </p:style>
-        <p:txBody>
-          <a:bodyPr rtlCol="0" anchor="ctr"/>
-          <a:lstStyle/>
-          <a:p>
-            <a:pPr algn="ctr"/>
-          </a:p>
-        </p:txBody>
-      </p:sp>
-      <p:sp>
-        <p:nvSpPr>
-          <p:cNvPr id="10" name="TextBox 9"/>
-          <p:cNvSpPr txBox="1"/>
-          <p:nvPr/>
-        </p:nvSpPr>
-        <p:spPr>
-          <a:xfrm>
-            <a:off x="960120" y="4206240"/>
-            <a:ext cx="10515600" cy="365760"/>
-          </a:xfrm>
-          <a:prstGeom prst="rect">
-            <a:avLst/>
-          </a:prstGeom>
-          <a:noFill/>
-        </p:spPr>
-        <p:txBody>
-          <a:bodyPr wrap="square">
-            <a:spAutoFit/>
-          </a:bodyPr>
-          <a:lstStyle/>
-          <a:p>
-            <a:pPr algn="l">
-              <a:defRPr sz="1700" b="1">
-                <a:solidFill>
-                  <a:srgbClr val="CCCCCC"/>
-                </a:solidFill>
-                <a:latin typeface="Calibri"/>
-              </a:defRPr>
-            </a:pPr>
-            <a:r>
-              <a:t>3  Progetto Org Graph</a:t>
-            </a:r>
-          </a:p>
-        </p:txBody>
-      </p:sp>
-      <p:sp>
-        <p:nvSpPr>
-          <p:cNvPr id="11" name="TextBox 10"/>
-          <p:cNvSpPr txBox="1"/>
-          <p:nvPr/>
-        </p:nvSpPr>
-        <p:spPr>
-          <a:xfrm>
-            <a:off x="960120" y="4572000"/>
-            <a:ext cx="10515600" cy="731520"/>
-          </a:xfrm>
-          <a:prstGeom prst="rect">
-            <a:avLst/>
-          </a:prstGeom>
-          <a:noFill/>
-        </p:spPr>
-        <p:txBody>
-          <a:bodyPr wrap="square">
-            <a:spAutoFit/>
-          </a:bodyPr>
-          <a:lstStyle/>
-          <a:p>
-            <a:pPr algn="l">
-              <a:defRPr sz="1300" b="0">
-                <a:solidFill>
-                  <a:srgbClr val="CCCCCC"/>
-                </a:solidFill>
-                <a:latin typeface="Calibri"/>
-              </a:defRPr>
-            </a:pPr>
-            <a:r>
-              <a:t>Applicazione dei concetti al dataset aziendale</a:t>
-            </a:r>
-            <a:br/>
-            <a:r>
-              <a:t>20–30 minuti</a:t>
-            </a:r>
-          </a:p>
-        </p:txBody>
-      </p:sp>
-      <p:sp>
-        <p:nvSpPr>
-          <p:cNvPr id="12" name="Rectangle 11"/>
-          <p:cNvSpPr/>
-          <p:nvPr/>
-        </p:nvSpPr>
-        <p:spPr>
-          <a:xfrm>
-            <a:off x="731520" y="5669280"/>
+            <a:off x="731520" y="4389120"/>
             <a:ext cx="10698480" cy="36576"/>
           </a:xfrm>
           <a:prstGeom prst="rect">
@@ -26515,13 +26376,13 @@
       </p:sp>
       <p:sp>
         <p:nvSpPr>
-          <p:cNvPr id="13" name="TextBox 12"/>
+          <p:cNvPr id="10" name="TextBox 9"/>
           <p:cNvSpPr txBox="1"/>
           <p:nvPr/>
         </p:nvSpPr>
         <p:spPr>
           <a:xfrm>
-            <a:off x="731520" y="5852160"/>
+            <a:off x="731520" y="4572000"/>
             <a:ext cx="10515600" cy="457200"/>
           </a:xfrm>
           <a:prstGeom prst="rect">
@@ -29184,22 +29045,6 @@
             </a:pPr>
             <a:r>
               <a:t>•  data/ — Dati CSV anonimizzati (I&amp;D HDP Skill Mapping)</a:t>
-            </a:r>
-          </a:p>
-          <a:p>
-            <a:pPr algn="l">
-              <a:spcAft>
-                <a:spcPts val="1200"/>
-              </a:spcAft>
-              <a:defRPr sz="1400">
-                <a:solidFill>
-                  <a:srgbClr val="FFFFFF"/>
-                </a:solidFill>
-                <a:latin typeface="Calibri"/>
-              </a:defRPr>
-            </a:pPr>
-            <a:r>
-              <a:t>•  scripts/ — Utility di generazione e setup</a:t>
             </a:r>
           </a:p>
         </p:txBody>

</xml_diff>